<commit_message>
Updated presentation - RBP Stuff - Needs review and possible changes
</commit_message>
<xml_diff>
--- a/Presentation/5x5FCS578.pptx
+++ b/Presentation/5x5FCS578.pptx
@@ -7,6 +7,10 @@
   <p:sldIdLst>
     <p:sldId id="256" r:id="rId2"/>
     <p:sldId id="257" r:id="rId3"/>
+    <p:sldId id="258" r:id="rId4"/>
+    <p:sldId id="259" r:id="rId5"/>
+    <p:sldId id="260" r:id="rId6"/>
+    <p:sldId id="261" r:id="rId7"/>
   </p:sldIdLst>
   <p:sldSz cx="12192000" cy="6858000"/>
   <p:notesSz cx="6858000" cy="9144000"/>
@@ -105,6 +109,11 @@
       </a:defRPr>
     </a:lvl9pPr>
   </p:defaultTextStyle>
+  <p:extLst>
+    <p:ext uri="{EFAFB233-063F-42B5-8137-9DF3F51BA10A}">
+      <p15:sldGuideLst xmlns:p15="http://schemas.microsoft.com/office/powerpoint/2012/main"/>
+    </p:ext>
+  </p:extLst>
 </p:presentation>
 </file>
 
@@ -6147,7 +6156,172 @@
         </p:nvSpPr>
         <p:spPr>
           <a:xfrm>
-            <a:off x="344040" y="920621"/>
+            <a:off x="344040" y="714775"/>
+            <a:ext cx="6525472" cy="5324535"/>
+          </a:xfrm>
+          <a:prstGeom prst="rect">
+            <a:avLst/>
+          </a:prstGeom>
+          <a:noFill/>
+        </p:spPr>
+        <p:txBody>
+          <a:bodyPr wrap="square" rtlCol="0">
+            <a:spAutoFit/>
+          </a:bodyPr>
+          <a:lstStyle/>
+          <a:p>
+            <a:pPr marL="285750" indent="-285750">
+              <a:buFont typeface="Wingdings" panose="05000000000000000000" pitchFamily="2" charset="2"/>
+              <a:buChar char="§"/>
+            </a:pPr>
+            <a:r>
+              <a:rPr lang="en-US" sz="2000" b="1" dirty="0"/>
+              <a:t>What we are building is a digital, easy to use and file, form FSA-578 to help New Mexico’s small farmers get and stay online.</a:t>
+            </a:r>
+          </a:p>
+          <a:p>
+            <a:pPr marL="285750" indent="-285750">
+              <a:buFont typeface="Wingdings" panose="05000000000000000000" pitchFamily="2" charset="2"/>
+              <a:buChar char="§"/>
+            </a:pPr>
+            <a:endParaRPr lang="en-US" sz="2000" b="1" dirty="0"/>
+          </a:p>
+          <a:p>
+            <a:pPr marL="285750" indent="-285750">
+              <a:buFont typeface="Wingdings" panose="05000000000000000000" pitchFamily="2" charset="2"/>
+              <a:buChar char="§"/>
+            </a:pPr>
+            <a:r>
+              <a:rPr lang="en-US" sz="2000" b="1" dirty="0"/>
+              <a:t>New Mexico’s agricultural infrastructure has lost one-fourth of its human capital in just 12 months. With 12+ offices closing and 2,600 experts gone.</a:t>
+            </a:r>
+          </a:p>
+          <a:p>
+            <a:pPr marL="285750" indent="-285750">
+              <a:buFont typeface="Wingdings" panose="05000000000000000000" pitchFamily="2" charset="2"/>
+              <a:buChar char="§"/>
+            </a:pPr>
+            <a:endParaRPr lang="en-US" sz="2000" b="1" dirty="0"/>
+          </a:p>
+          <a:p>
+            <a:pPr marL="285750" indent="-285750">
+              <a:buFont typeface="Wingdings" panose="05000000000000000000" pitchFamily="2" charset="2"/>
+              <a:buChar char="§"/>
+            </a:pPr>
+            <a:r>
+              <a:rPr lang="en-US" sz="2000" b="1" dirty="0"/>
+              <a:t>To file these forms the old way, a farmer must make an appointment at a local office to manually certify the form or use their kiosks which could be 100 miles away.</a:t>
+            </a:r>
+          </a:p>
+          <a:p>
+            <a:pPr marL="285750" indent="-285750">
+              <a:buFont typeface="Wingdings" panose="05000000000000000000" pitchFamily="2" charset="2"/>
+              <a:buChar char="§"/>
+            </a:pPr>
+            <a:endParaRPr lang="en-US" sz="2000" b="1" dirty="0"/>
+          </a:p>
+          <a:p>
+            <a:pPr marL="285750" indent="-285750">
+              <a:buFont typeface="Wingdings" panose="05000000000000000000" pitchFamily="2" charset="2"/>
+              <a:buChar char="§"/>
+            </a:pPr>
+            <a:r>
+              <a:rPr lang="en-US" sz="2000" b="1" dirty="0"/>
+              <a:t>However, this form can be filed online, but the formats the government accepts are very specific and complicated (JSON/XML/SHP) and any single mistake will cause it to be rejected it.</a:t>
+            </a:r>
+          </a:p>
+        </p:txBody>
+      </p:sp>
+    </p:spTree>
+    <p:extLst>
+      <p:ext uri="{BB962C8B-B14F-4D97-AF65-F5344CB8AC3E}">
+        <p14:creationId xmlns:p14="http://schemas.microsoft.com/office/powerpoint/2010/main" val="2713165969"/>
+      </p:ext>
+    </p:extLst>
+  </p:cSld>
+  <p:clrMapOvr>
+    <a:masterClrMapping/>
+  </p:clrMapOvr>
+</p:sld>
+</file>
+
+<file path=ppt/slides/slide3.xml><?xml version="1.0" encoding="utf-8"?>
+<p:sld xmlns:a="http://schemas.openxmlformats.org/drawingml/2006/main" xmlns:r="http://schemas.openxmlformats.org/officeDocument/2006/relationships" xmlns:p="http://schemas.openxmlformats.org/presentationml/2006/main">
+  <p:cSld>
+    <p:spTree>
+      <p:nvGrpSpPr>
+        <p:cNvPr id="1" name="">
+          <a:extLst>
+            <a:ext uri="{FF2B5EF4-FFF2-40B4-BE49-F238E27FC236}">
+              <a16:creationId xmlns:a16="http://schemas.microsoft.com/office/drawing/2014/main" id="{33C27EAA-DD0A-FC86-E6DC-9BA4D4AE9416}"/>
+            </a:ext>
+          </a:extLst>
+        </p:cNvPr>
+        <p:cNvGrpSpPr/>
+        <p:nvPr/>
+      </p:nvGrpSpPr>
+      <p:grpSpPr>
+        <a:xfrm>
+          <a:off x="0" y="0"/>
+          <a:ext cx="0" cy="0"/>
+          <a:chOff x="0" y="0"/>
+          <a:chExt cx="0" cy="0"/>
+        </a:xfrm>
+      </p:grpSpPr>
+      <p:sp>
+        <p:nvSpPr>
+          <p:cNvPr id="2" name="Title 1">
+            <a:extLst>
+              <a:ext uri="{FF2B5EF4-FFF2-40B4-BE49-F238E27FC236}">
+                <a16:creationId xmlns:a16="http://schemas.microsoft.com/office/drawing/2014/main" id="{F19D86DE-5AED-95CA-C111-B217E29DF075}"/>
+              </a:ext>
+            </a:extLst>
+          </p:cNvPr>
+          <p:cNvSpPr>
+            <a:spLocks noGrp="1"/>
+          </p:cNvSpPr>
+          <p:nvPr>
+            <p:ph type="title"/>
+          </p:nvPr>
+        </p:nvSpPr>
+        <p:spPr>
+          <a:xfrm rot="5400000">
+            <a:off x="10492340" y="4965976"/>
+            <a:ext cx="3003884" cy="347028"/>
+          </a:xfrm>
+        </p:spPr>
+        <p:txBody>
+          <a:bodyPr>
+            <a:normAutofit fontScale="90000"/>
+          </a:bodyPr>
+          <a:lstStyle/>
+          <a:p>
+            <a:r>
+              <a:rPr lang="en-US" sz="2800" b="1" dirty="0">
+                <a:solidFill>
+                  <a:schemeClr val="bg1"/>
+                </a:solidFill>
+              </a:rPr>
+              <a:t>GREENER 5X5 </a:t>
+            </a:r>
+          </a:p>
+        </p:txBody>
+      </p:sp>
+      <p:sp>
+        <p:nvSpPr>
+          <p:cNvPr id="5" name="TextBox 4">
+            <a:extLst>
+              <a:ext uri="{FF2B5EF4-FFF2-40B4-BE49-F238E27FC236}">
+                <a16:creationId xmlns:a16="http://schemas.microsoft.com/office/drawing/2014/main" id="{53DF425A-3B8D-9D48-E9F5-A176CA826FCD}"/>
+              </a:ext>
+            </a:extLst>
+          </p:cNvPr>
+          <p:cNvSpPr txBox="1"/>
+          <p:nvPr/>
+        </p:nvSpPr>
+        <p:spPr>
+          <a:xfrm>
+            <a:off x="225941" y="558755"/>
             <a:ext cx="6525472" cy="5016758"/>
           </a:xfrm>
           <a:prstGeom prst="rect">
@@ -6165,11 +6339,697 @@
               <a:buFont typeface="Wingdings" panose="05000000000000000000" pitchFamily="2" charset="2"/>
               <a:buChar char="§"/>
             </a:pPr>
+            <a:endParaRPr lang="en-US" sz="2000" b="1" dirty="0"/>
+          </a:p>
+          <a:p>
+            <a:pPr marL="285750" indent="-285750">
+              <a:buFont typeface="Wingdings" panose="05000000000000000000" pitchFamily="2" charset="2"/>
+              <a:buChar char="§"/>
+            </a:pPr>
             <a:r>
               <a:rPr lang="en-US" sz="2000" b="1" dirty="0"/>
-              <a:t>What we are building is a digital, easy to use and file form FSA-578 form to help New Mexico’s $4B ag economy get and stay online.</a:t>
-            </a:r>
-          </a:p>
+              <a:t>Filing this specific form opens up a vast amount of government resources, grants, insurance, and tax advantages for the farmer.</a:t>
+            </a:r>
+          </a:p>
+          <a:p>
+            <a:endParaRPr lang="en-US" sz="2000" b="1" dirty="0"/>
+          </a:p>
+          <a:p>
+            <a:pPr lvl="1"/>
+            <a:r>
+              <a:rPr lang="en-US" sz="2000" b="1" dirty="0"/>
+              <a:t>-	Value added agriculture grants</a:t>
+            </a:r>
+          </a:p>
+          <a:p>
+            <a:pPr lvl="1"/>
+            <a:r>
+              <a:rPr lang="en-US" sz="2000" b="1" dirty="0"/>
+              <a:t>-	REAP grants (energy assessment)</a:t>
+            </a:r>
+          </a:p>
+          <a:p>
+            <a:pPr lvl="1"/>
+            <a:r>
+              <a:rPr lang="en-US" sz="2000" b="1" dirty="0"/>
+              <a:t>-	EQIP grants</a:t>
+            </a:r>
+          </a:p>
+          <a:p>
+            <a:pPr lvl="1"/>
+            <a:r>
+              <a:rPr lang="en-US" sz="2000" b="1" dirty="0"/>
+              <a:t>-	Poultry &amp; meat processing grants</a:t>
+            </a:r>
+          </a:p>
+          <a:p>
+            <a:pPr lvl="1"/>
+            <a:r>
+              <a:rPr lang="en-US" sz="2000" b="1" dirty="0"/>
+              <a:t>-	LFPP local food promotion</a:t>
+            </a:r>
+          </a:p>
+          <a:p>
+            <a:pPr lvl="1"/>
+            <a:r>
+              <a:rPr lang="en-US" sz="2000" b="1" dirty="0"/>
+              <a:t>-	HFFI healthy food financing initiative grants</a:t>
+            </a:r>
+          </a:p>
+          <a:p>
+            <a:pPr marL="800100" lvl="1" indent="-342900">
+              <a:buFontTx/>
+              <a:buChar char="-"/>
+            </a:pPr>
+            <a:r>
+              <a:rPr lang="en-US" sz="2000" b="1" dirty="0"/>
+              <a:t>  and others….</a:t>
+            </a:r>
+          </a:p>
+          <a:p>
+            <a:pPr marL="800100" lvl="1" indent="-342900">
+              <a:buFont typeface="Arial" panose="020B0604020202020204" pitchFamily="34" charset="0"/>
+              <a:buChar char="•"/>
+            </a:pPr>
+            <a:endParaRPr lang="en-US" sz="2000" b="1" dirty="0"/>
+          </a:p>
+          <a:p>
+            <a:pPr marL="342900" indent="-342900">
+              <a:buFont typeface="Arial" panose="020B0604020202020204" pitchFamily="34" charset="0"/>
+              <a:buChar char="•"/>
+            </a:pPr>
+            <a:r>
+              <a:rPr lang="en-US" sz="2000" b="1" dirty="0"/>
+              <a:t>This form is accepted by almost all county and state agencies in New Mexico.</a:t>
+            </a:r>
+          </a:p>
+          <a:p>
+            <a:endParaRPr lang="en-US" sz="2000" b="1" dirty="0"/>
+          </a:p>
+        </p:txBody>
+      </p:sp>
+      <p:pic>
+        <p:nvPicPr>
+          <p:cNvPr id="1026" name="Picture 2" descr="Farm financing resources for equipment and infrastructure">
+            <a:extLst>
+              <a:ext uri="{FF2B5EF4-FFF2-40B4-BE49-F238E27FC236}">
+                <a16:creationId xmlns:a16="http://schemas.microsoft.com/office/drawing/2014/main" id="{D6E29B33-556A-F159-CF7B-507ACCA1D57B}"/>
+              </a:ext>
+            </a:extLst>
+          </p:cNvPr>
+          <p:cNvPicPr>
+            <a:picLocks noChangeAspect="1" noChangeArrowheads="1"/>
+          </p:cNvPicPr>
+          <p:nvPr/>
+        </p:nvPicPr>
+        <p:blipFill>
+          <a:blip r:embed="rId2">
+            <a:extLst>
+              <a:ext uri="{28A0092B-C50C-407E-A947-70E740481C1C}">
+                <a14:useLocalDpi xmlns:a14="http://schemas.microsoft.com/office/drawing/2010/main" val="0"/>
+              </a:ext>
+            </a:extLst>
+          </a:blip>
+          <a:srcRect/>
+          <a:stretch>
+            <a:fillRect/>
+          </a:stretch>
+        </p:blipFill>
+        <p:spPr bwMode="auto">
+          <a:xfrm>
+            <a:off x="7010189" y="1282486"/>
+            <a:ext cx="4293027" cy="4293027"/>
+          </a:xfrm>
+          <a:prstGeom prst="rect">
+            <a:avLst/>
+          </a:prstGeom>
+          <a:noFill/>
+          <a:extLst>
+            <a:ext uri="{909E8E84-426E-40DD-AFC4-6F175D3DCCD1}">
+              <a14:hiddenFill xmlns:a14="http://schemas.microsoft.com/office/drawing/2010/main">
+                <a:solidFill>
+                  <a:srgbClr val="FFFFFF"/>
+                </a:solidFill>
+              </a14:hiddenFill>
+            </a:ext>
+          </a:extLst>
+        </p:spPr>
+      </p:pic>
+    </p:spTree>
+    <p:extLst>
+      <p:ext uri="{BB962C8B-B14F-4D97-AF65-F5344CB8AC3E}">
+        <p14:creationId xmlns:p14="http://schemas.microsoft.com/office/powerpoint/2010/main" val="2303473611"/>
+      </p:ext>
+    </p:extLst>
+  </p:cSld>
+  <p:clrMapOvr>
+    <a:masterClrMapping/>
+  </p:clrMapOvr>
+</p:sld>
+</file>
+
+<file path=ppt/slides/slide4.xml><?xml version="1.0" encoding="utf-8"?>
+<p:sld xmlns:a="http://schemas.openxmlformats.org/drawingml/2006/main" xmlns:r="http://schemas.openxmlformats.org/officeDocument/2006/relationships" xmlns:p="http://schemas.openxmlformats.org/presentationml/2006/main">
+  <p:cSld>
+    <p:spTree>
+      <p:nvGrpSpPr>
+        <p:cNvPr id="1" name="">
+          <a:extLst>
+            <a:ext uri="{FF2B5EF4-FFF2-40B4-BE49-F238E27FC236}">
+              <a16:creationId xmlns:a16="http://schemas.microsoft.com/office/drawing/2014/main" id="{52B5D389-6F2C-8D79-0919-B85EBA0F568B}"/>
+            </a:ext>
+          </a:extLst>
+        </p:cNvPr>
+        <p:cNvGrpSpPr/>
+        <p:nvPr/>
+      </p:nvGrpSpPr>
+      <p:grpSpPr>
+        <a:xfrm>
+          <a:off x="0" y="0"/>
+          <a:ext cx="0" cy="0"/>
+          <a:chOff x="0" y="0"/>
+          <a:chExt cx="0" cy="0"/>
+        </a:xfrm>
+      </p:grpSpPr>
+      <p:pic>
+        <p:nvPicPr>
+          <p:cNvPr id="8" name="Picture 7">
+            <a:extLst>
+              <a:ext uri="{FF2B5EF4-FFF2-40B4-BE49-F238E27FC236}">
+                <a16:creationId xmlns:a16="http://schemas.microsoft.com/office/drawing/2014/main" id="{91CA4B39-3911-047F-885B-6091853907ED}"/>
+              </a:ext>
+            </a:extLst>
+          </p:cNvPr>
+          <p:cNvPicPr>
+            <a:picLocks noChangeAspect="1"/>
+          </p:cNvPicPr>
+          <p:nvPr/>
+        </p:nvPicPr>
+        <p:blipFill>
+          <a:blip r:embed="rId2">
+            <a:extLst>
+              <a:ext uri="{28A0092B-C50C-407E-A947-70E740481C1C}">
+                <a14:useLocalDpi xmlns:a14="http://schemas.microsoft.com/office/drawing/2010/main" val="0"/>
+              </a:ext>
+            </a:extLst>
+          </a:blip>
+          <a:stretch>
+            <a:fillRect/>
+          </a:stretch>
+        </p:blipFill>
+        <p:spPr>
+          <a:xfrm>
+            <a:off x="1074363" y="485335"/>
+            <a:ext cx="7618008" cy="5887330"/>
+          </a:xfrm>
+          <a:prstGeom prst="rect">
+            <a:avLst/>
+          </a:prstGeom>
+        </p:spPr>
+      </p:pic>
+      <p:sp>
+        <p:nvSpPr>
+          <p:cNvPr id="2" name="Title 1">
+            <a:extLst>
+              <a:ext uri="{FF2B5EF4-FFF2-40B4-BE49-F238E27FC236}">
+                <a16:creationId xmlns:a16="http://schemas.microsoft.com/office/drawing/2014/main" id="{AF4CF346-E9D1-FDB1-B836-FAD0C7C3C5B3}"/>
+              </a:ext>
+            </a:extLst>
+          </p:cNvPr>
+          <p:cNvSpPr>
+            <a:spLocks noGrp="1"/>
+          </p:cNvSpPr>
+          <p:nvPr>
+            <p:ph type="title"/>
+          </p:nvPr>
+        </p:nvSpPr>
+        <p:spPr>
+          <a:xfrm rot="5400000">
+            <a:off x="10492340" y="4965976"/>
+            <a:ext cx="3003884" cy="347028"/>
+          </a:xfrm>
+        </p:spPr>
+        <p:txBody>
+          <a:bodyPr>
+            <a:normAutofit fontScale="90000"/>
+          </a:bodyPr>
+          <a:lstStyle/>
+          <a:p>
+            <a:r>
+              <a:rPr lang="en-US" sz="2800" b="1" dirty="0">
+                <a:solidFill>
+                  <a:schemeClr val="bg1"/>
+                </a:solidFill>
+              </a:rPr>
+              <a:t>GREENER 5X5 </a:t>
+            </a:r>
+          </a:p>
+        </p:txBody>
+      </p:sp>
+      <p:pic>
+        <p:nvPicPr>
+          <p:cNvPr id="6" name="Picture 5">
+            <a:extLst>
+              <a:ext uri="{FF2B5EF4-FFF2-40B4-BE49-F238E27FC236}">
+                <a16:creationId xmlns:a16="http://schemas.microsoft.com/office/drawing/2014/main" id="{EC7A8B45-D904-5FDA-23D0-1815D6E73691}"/>
+              </a:ext>
+            </a:extLst>
+          </p:cNvPr>
+          <p:cNvPicPr>
+            <a:picLocks noChangeAspect="1"/>
+          </p:cNvPicPr>
+          <p:nvPr/>
+        </p:nvPicPr>
+        <p:blipFill>
+          <a:blip r:embed="rId3">
+            <a:extLst>
+              <a:ext uri="{28A0092B-C50C-407E-A947-70E740481C1C}">
+                <a14:useLocalDpi xmlns:a14="http://schemas.microsoft.com/office/drawing/2010/main" val="0"/>
+              </a:ext>
+            </a:extLst>
+          </a:blip>
+          <a:stretch>
+            <a:fillRect/>
+          </a:stretch>
+        </p:blipFill>
+        <p:spPr>
+          <a:xfrm>
+            <a:off x="1074363" y="485336"/>
+            <a:ext cx="7534874" cy="5887329"/>
+          </a:xfrm>
+          <a:prstGeom prst="rect">
+            <a:avLst/>
+          </a:prstGeom>
+        </p:spPr>
+      </p:pic>
+    </p:spTree>
+    <p:extLst>
+      <p:ext uri="{BB962C8B-B14F-4D97-AF65-F5344CB8AC3E}">
+        <p14:creationId xmlns:p14="http://schemas.microsoft.com/office/powerpoint/2010/main" val="1180710650"/>
+      </p:ext>
+    </p:extLst>
+  </p:cSld>
+  <p:clrMapOvr>
+    <a:masterClrMapping/>
+  </p:clrMapOvr>
+  <p:timing>
+    <p:tnLst>
+      <p:par>
+        <p:cTn id="1" dur="indefinite" restart="never" nodeType="tmRoot">
+          <p:childTnLst>
+            <p:seq concurrent="1" nextAc="seek">
+              <p:cTn id="2" dur="indefinite" nodeType="mainSeq">
+                <p:childTnLst>
+                  <p:par>
+                    <p:cTn id="3" fill="hold">
+                      <p:stCondLst>
+                        <p:cond delay="indefinite"/>
+                      </p:stCondLst>
+                      <p:childTnLst>
+                        <p:par>
+                          <p:cTn id="4" fill="hold">
+                            <p:stCondLst>
+                              <p:cond delay="0"/>
+                            </p:stCondLst>
+                            <p:childTnLst>
+                              <p:par>
+                                <p:cTn id="5" presetID="1" presetClass="exit" presetSubtype="0" fill="hold" nodeType="clickEffect">
+                                  <p:stCondLst>
+                                    <p:cond delay="0"/>
+                                  </p:stCondLst>
+                                  <p:childTnLst>
+                                    <p:set>
+                                      <p:cBhvr>
+                                        <p:cTn id="6" dur="1" fill="hold">
+                                          <p:stCondLst>
+                                            <p:cond delay="0"/>
+                                          </p:stCondLst>
+                                        </p:cTn>
+                                        <p:tgtEl>
+                                          <p:spTgt spid="6"/>
+                                        </p:tgtEl>
+                                        <p:attrNameLst>
+                                          <p:attrName>style.visibility</p:attrName>
+                                        </p:attrNameLst>
+                                      </p:cBhvr>
+                                      <p:to>
+                                        <p:strVal val="hidden"/>
+                                      </p:to>
+                                    </p:set>
+                                  </p:childTnLst>
+                                </p:cTn>
+                              </p:par>
+                            </p:childTnLst>
+                          </p:cTn>
+                        </p:par>
+                      </p:childTnLst>
+                    </p:cTn>
+                  </p:par>
+                </p:childTnLst>
+              </p:cTn>
+              <p:prevCondLst>
+                <p:cond evt="onPrev" delay="0">
+                  <p:tgtEl>
+                    <p:sldTgt/>
+                  </p:tgtEl>
+                </p:cond>
+              </p:prevCondLst>
+              <p:nextCondLst>
+                <p:cond evt="onNext" delay="0">
+                  <p:tgtEl>
+                    <p:sldTgt/>
+                  </p:tgtEl>
+                </p:cond>
+              </p:nextCondLst>
+            </p:seq>
+          </p:childTnLst>
+        </p:cTn>
+      </p:par>
+    </p:tnLst>
+  </p:timing>
+</p:sld>
+</file>
+
+<file path=ppt/slides/slide5.xml><?xml version="1.0" encoding="utf-8"?>
+<p:sld xmlns:a="http://schemas.openxmlformats.org/drawingml/2006/main" xmlns:r="http://schemas.openxmlformats.org/officeDocument/2006/relationships" xmlns:p="http://schemas.openxmlformats.org/presentationml/2006/main">
+  <p:cSld>
+    <p:spTree>
+      <p:nvGrpSpPr>
+        <p:cNvPr id="1" name=""/>
+        <p:cNvGrpSpPr/>
+        <p:nvPr/>
+      </p:nvGrpSpPr>
+      <p:grpSpPr>
+        <a:xfrm>
+          <a:off x="0" y="0"/>
+          <a:ext cx="0" cy="0"/>
+          <a:chOff x="0" y="0"/>
+          <a:chExt cx="0" cy="0"/>
+        </a:xfrm>
+      </p:grpSpPr>
+      <p:sp>
+        <p:nvSpPr>
+          <p:cNvPr id="2" name="Title 1">
+            <a:extLst>
+              <a:ext uri="{FF2B5EF4-FFF2-40B4-BE49-F238E27FC236}">
+                <a16:creationId xmlns:a16="http://schemas.microsoft.com/office/drawing/2014/main" id="{A8911A09-D145-A248-CB18-3CE85A87EA01}"/>
+              </a:ext>
+            </a:extLst>
+          </p:cNvPr>
+          <p:cNvSpPr>
+            <a:spLocks noGrp="1"/>
+          </p:cNvSpPr>
+          <p:nvPr>
+            <p:ph type="title"/>
+          </p:nvPr>
+        </p:nvSpPr>
+        <p:spPr>
+          <a:xfrm>
+            <a:off x="4067647" y="935486"/>
+            <a:ext cx="1784512" cy="1320800"/>
+          </a:xfrm>
+        </p:spPr>
+        <p:txBody>
+          <a:bodyPr/>
+          <a:lstStyle/>
+          <a:p>
+            <a:r>
+              <a:rPr lang="en-US" b="1" dirty="0"/>
+              <a:t>DEMO</a:t>
+            </a:r>
+          </a:p>
+        </p:txBody>
+      </p:sp>
+      <p:pic>
+        <p:nvPicPr>
+          <p:cNvPr id="7" name="Picture 6">
+            <a:extLst>
+              <a:ext uri="{FF2B5EF4-FFF2-40B4-BE49-F238E27FC236}">
+                <a16:creationId xmlns:a16="http://schemas.microsoft.com/office/drawing/2014/main" id="{4CF0D70F-01A7-DA63-2E14-1E4E6803A261}"/>
+              </a:ext>
+            </a:extLst>
+          </p:cNvPr>
+          <p:cNvPicPr>
+            <a:picLocks noChangeAspect="1"/>
+          </p:cNvPicPr>
+          <p:nvPr/>
+        </p:nvPicPr>
+        <p:blipFill>
+          <a:blip r:embed="rId2">
+            <a:extLst>
+              <a:ext uri="{28A0092B-C50C-407E-A947-70E740481C1C}">
+                <a14:useLocalDpi xmlns:a14="http://schemas.microsoft.com/office/drawing/2010/main" val="0"/>
+              </a:ext>
+            </a:extLst>
+          </a:blip>
+          <a:stretch>
+            <a:fillRect/>
+          </a:stretch>
+        </p:blipFill>
+        <p:spPr>
+          <a:xfrm>
+            <a:off x="1204156" y="1777984"/>
+            <a:ext cx="7511493" cy="3954601"/>
+          </a:xfrm>
+          <a:prstGeom prst="rect">
+            <a:avLst/>
+          </a:prstGeom>
+        </p:spPr>
+      </p:pic>
+    </p:spTree>
+    <p:extLst>
+      <p:ext uri="{BB962C8B-B14F-4D97-AF65-F5344CB8AC3E}">
+        <p14:creationId xmlns:p14="http://schemas.microsoft.com/office/powerpoint/2010/main" val="2201743322"/>
+      </p:ext>
+    </p:extLst>
+  </p:cSld>
+  <p:clrMapOvr>
+    <a:masterClrMapping/>
+  </p:clrMapOvr>
+</p:sld>
+</file>
+
+<file path=ppt/slides/slide6.xml><?xml version="1.0" encoding="utf-8"?>
+<p:sld xmlns:a="http://schemas.openxmlformats.org/drawingml/2006/main" xmlns:r="http://schemas.openxmlformats.org/officeDocument/2006/relationships" xmlns:p="http://schemas.openxmlformats.org/presentationml/2006/main">
+  <p:cSld>
+    <p:spTree>
+      <p:nvGrpSpPr>
+        <p:cNvPr id="1" name="">
+          <a:extLst>
+            <a:ext uri="{FF2B5EF4-FFF2-40B4-BE49-F238E27FC236}">
+              <a16:creationId xmlns:a16="http://schemas.microsoft.com/office/drawing/2014/main" id="{7CDB1556-CB4B-C710-9A84-8090B5D730A4}"/>
+            </a:ext>
+          </a:extLst>
+        </p:cNvPr>
+        <p:cNvGrpSpPr/>
+        <p:nvPr/>
+      </p:nvGrpSpPr>
+      <p:grpSpPr>
+        <a:xfrm>
+          <a:off x="0" y="0"/>
+          <a:ext cx="0" cy="0"/>
+          <a:chOff x="0" y="0"/>
+          <a:chExt cx="0" cy="0"/>
+        </a:xfrm>
+      </p:grpSpPr>
+      <p:sp>
+        <p:nvSpPr>
+          <p:cNvPr id="2" name="Title 1">
+            <a:extLst>
+              <a:ext uri="{FF2B5EF4-FFF2-40B4-BE49-F238E27FC236}">
+                <a16:creationId xmlns:a16="http://schemas.microsoft.com/office/drawing/2014/main" id="{66BB6C90-DE3D-D87D-1DC4-6061D63440C5}"/>
+              </a:ext>
+            </a:extLst>
+          </p:cNvPr>
+          <p:cNvSpPr>
+            <a:spLocks noGrp="1"/>
+          </p:cNvSpPr>
+          <p:nvPr>
+            <p:ph type="title"/>
+          </p:nvPr>
+        </p:nvSpPr>
+        <p:spPr>
+          <a:xfrm rot="5400000">
+            <a:off x="10492340" y="4965976"/>
+            <a:ext cx="3003884" cy="347028"/>
+          </a:xfrm>
+        </p:spPr>
+        <p:txBody>
+          <a:bodyPr>
+            <a:normAutofit fontScale="90000"/>
+          </a:bodyPr>
+          <a:lstStyle/>
+          <a:p>
+            <a:r>
+              <a:rPr lang="en-US" sz="2800" b="1" dirty="0">
+                <a:solidFill>
+                  <a:schemeClr val="bg1"/>
+                </a:solidFill>
+              </a:rPr>
+              <a:t>GREENER 5X5 </a:t>
+            </a:r>
+          </a:p>
+        </p:txBody>
+      </p:sp>
+      <p:sp>
+        <p:nvSpPr>
+          <p:cNvPr id="5" name="TextBox 4">
+            <a:extLst>
+              <a:ext uri="{FF2B5EF4-FFF2-40B4-BE49-F238E27FC236}">
+                <a16:creationId xmlns:a16="http://schemas.microsoft.com/office/drawing/2014/main" id="{3B3C809F-5F33-0C6F-6C15-7C271CA9E902}"/>
+              </a:ext>
+            </a:extLst>
+          </p:cNvPr>
+          <p:cNvSpPr txBox="1"/>
+          <p:nvPr/>
+        </p:nvSpPr>
+        <p:spPr>
+          <a:xfrm>
+            <a:off x="442511" y="2449130"/>
+            <a:ext cx="8012169" cy="3785652"/>
+          </a:xfrm>
+          <a:prstGeom prst="rect">
+            <a:avLst/>
+          </a:prstGeom>
+          <a:noFill/>
+        </p:spPr>
+        <p:txBody>
+          <a:bodyPr wrap="square" rtlCol="0">
+            <a:spAutoFit/>
+          </a:bodyPr>
+          <a:lstStyle/>
+          <a:p>
+            <a:endParaRPr lang="en-US" sz="2000" b="1" dirty="0"/>
+          </a:p>
+          <a:p>
+            <a:pPr marL="285750" indent="-285750">
+              <a:buFont typeface="Wingdings" panose="05000000000000000000" pitchFamily="2" charset="2"/>
+              <a:buChar char="§"/>
+            </a:pPr>
+            <a:r>
+              <a:rPr lang="en-US" sz="2000" b="1" dirty="0"/>
+              <a:t>Goals</a:t>
+            </a:r>
+          </a:p>
+          <a:p>
+            <a:pPr marL="742950" lvl="1" indent="-285750">
+              <a:buFont typeface="Wingdings" panose="05000000000000000000" pitchFamily="2" charset="2"/>
+              <a:buChar char="§"/>
+            </a:pPr>
+            <a:r>
+              <a:rPr lang="en-US" sz="2000" b="1" dirty="0"/>
+              <a:t>Make it easy for farmers to use</a:t>
+            </a:r>
+          </a:p>
+          <a:p>
+            <a:pPr marL="742950" lvl="1" indent="-285750">
+              <a:buFont typeface="Wingdings" panose="05000000000000000000" pitchFamily="2" charset="2"/>
+              <a:buChar char="§"/>
+            </a:pPr>
+            <a:r>
+              <a:rPr lang="en-US" sz="2000" b="1" dirty="0"/>
+              <a:t>Eliminate visits to the USDA</a:t>
+            </a:r>
+          </a:p>
+          <a:p>
+            <a:pPr marL="742950" lvl="1" indent="-285750">
+              <a:buFont typeface="Wingdings" panose="05000000000000000000" pitchFamily="2" charset="2"/>
+              <a:buChar char="§"/>
+            </a:pPr>
+            <a:r>
+              <a:rPr lang="en-US" sz="2000" b="1" dirty="0"/>
+              <a:t>Generate complicated submission data</a:t>
+            </a:r>
+          </a:p>
+          <a:p>
+            <a:pPr marL="742950" lvl="1" indent="-285750">
+              <a:buFont typeface="Wingdings" panose="05000000000000000000" pitchFamily="2" charset="2"/>
+              <a:buChar char="§"/>
+            </a:pPr>
+            <a:r>
+              <a:rPr lang="en-US" sz="2000" b="1" dirty="0"/>
+              <a:t>Track key dates for submission and generate reminders</a:t>
+            </a:r>
+          </a:p>
+          <a:p>
+            <a:pPr marL="742950" lvl="1" indent="-285750">
+              <a:buFont typeface="Wingdings" panose="05000000000000000000" pitchFamily="2" charset="2"/>
+              <a:buChar char="§"/>
+            </a:pPr>
+            <a:r>
+              <a:rPr lang="en-US" sz="2000" b="1" dirty="0"/>
+              <a:t>Allow easy field location and crop info</a:t>
+            </a:r>
+          </a:p>
+          <a:p>
+            <a:pPr marL="742950" lvl="1" indent="-285750">
+              <a:buFont typeface="Wingdings" panose="05000000000000000000" pitchFamily="2" charset="2"/>
+              <a:buChar char="§"/>
+            </a:pPr>
+            <a:r>
+              <a:rPr lang="en-US" sz="2000" b="1" dirty="0"/>
+              <a:t>Allow duplicate data to be used on multiple forms</a:t>
+            </a:r>
+          </a:p>
+          <a:p>
+            <a:pPr marL="742950" lvl="1" indent="-285750">
+              <a:buFont typeface="Wingdings" panose="05000000000000000000" pitchFamily="2" charset="2"/>
+              <a:buChar char="§"/>
+            </a:pPr>
+            <a:r>
+              <a:rPr lang="en-US" sz="2000" b="1" dirty="0"/>
+              <a:t>Walk throughs/Links on USDA access/forms generation</a:t>
+            </a:r>
+          </a:p>
+          <a:p>
+            <a:pPr marL="742950" lvl="1" indent="-285750">
+              <a:buFont typeface="Wingdings" panose="05000000000000000000" pitchFamily="2" charset="2"/>
+              <a:buChar char="§"/>
+            </a:pPr>
+            <a:r>
+              <a:rPr lang="en-US" sz="2000" b="1" dirty="0"/>
+              <a:t>Free to NM Farmers under a certain size (10 Acres??)</a:t>
+            </a:r>
+          </a:p>
+          <a:p>
+            <a:pPr marL="800100" lvl="1" indent="-342900">
+              <a:buFont typeface="Arial" panose="020B0604020202020204" pitchFamily="34" charset="0"/>
+              <a:buChar char="•"/>
+            </a:pPr>
+            <a:endParaRPr lang="en-US" sz="2000" b="1" dirty="0"/>
+          </a:p>
+          <a:p>
+            <a:endParaRPr lang="en-US" sz="2000" b="1" dirty="0"/>
+          </a:p>
+        </p:txBody>
+      </p:sp>
+      <p:sp>
+        <p:nvSpPr>
+          <p:cNvPr id="3" name="TextBox 2">
+            <a:extLst>
+              <a:ext uri="{FF2B5EF4-FFF2-40B4-BE49-F238E27FC236}">
+                <a16:creationId xmlns:a16="http://schemas.microsoft.com/office/drawing/2014/main" id="{66DC1122-DE4B-66C8-8855-4E86D57125F5}"/>
+              </a:ext>
+            </a:extLst>
+          </p:cNvPr>
+          <p:cNvSpPr txBox="1"/>
+          <p:nvPr/>
+        </p:nvSpPr>
+        <p:spPr>
+          <a:xfrm>
+            <a:off x="442511" y="0"/>
+            <a:ext cx="8012169" cy="2554545"/>
+          </a:xfrm>
+          <a:prstGeom prst="rect">
+            <a:avLst/>
+          </a:prstGeom>
+          <a:noFill/>
+        </p:spPr>
+        <p:txBody>
+          <a:bodyPr wrap="square" rtlCol="0">
+            <a:spAutoFit/>
+          </a:bodyPr>
+          <a:lstStyle/>
           <a:p>
             <a:pPr marL="285750" indent="-285750">
               <a:buFont typeface="Wingdings" panose="05000000000000000000" pitchFamily="2" charset="2"/>
@@ -6183,50 +7043,73 @@
               <a:buChar char="§"/>
             </a:pPr>
             <a:r>
-              <a:rPr lang="en-US" sz="2000" b="1" dirty="0"/>
-              <a:t>New Mexico’s agricultural infrastructure has lost one-fourth of its human capital in just 12 months. With 12+ offices closing and 2,600 experts gone.</a:t>
-            </a:r>
-          </a:p>
-          <a:p>
-            <a:pPr marL="285750" indent="-285750">
+              <a:rPr lang="en-US" sz="2000" dirty="0"/>
+              <a:t>Competition</a:t>
+            </a:r>
+          </a:p>
+          <a:p>
+            <a:pPr marL="742950" lvl="1" indent="-285750">
               <a:buFont typeface="Wingdings" panose="05000000000000000000" pitchFamily="2" charset="2"/>
               <a:buChar char="§"/>
             </a:pPr>
-            <a:endParaRPr lang="en-US" sz="2000" b="1" dirty="0"/>
-          </a:p>
-          <a:p>
-            <a:pPr marL="285750" indent="-285750">
+            <a:r>
+              <a:rPr lang="en-US" sz="2000" dirty="0" err="1"/>
+              <a:t>MyAgData</a:t>
+            </a:r>
+            <a:r>
+              <a:rPr lang="en-US" sz="2000" dirty="0"/>
+              <a:t> - $250/report</a:t>
+            </a:r>
+          </a:p>
+          <a:p>
+            <a:pPr marL="1200150" lvl="2" indent="-285750">
               <a:buFont typeface="Wingdings" panose="05000000000000000000" pitchFamily="2" charset="2"/>
               <a:buChar char="§"/>
             </a:pPr>
             <a:r>
-              <a:rPr lang="en-US" sz="2000" b="1" dirty="0"/>
-              <a:t>To file these forms the old manual, visit to an office could not require up to a 100-mile drive by the farmer.</a:t>
-            </a:r>
-          </a:p>
-          <a:p>
-            <a:pPr marL="285750" indent="-285750">
+              <a:rPr lang="en-US" sz="2000" dirty="0"/>
+              <a:t>Pulls data from John Deer, Case IH, others</a:t>
+            </a:r>
+          </a:p>
+          <a:p>
+            <a:pPr marL="742950" lvl="1" indent="-285750">
               <a:buFont typeface="Wingdings" panose="05000000000000000000" pitchFamily="2" charset="2"/>
               <a:buChar char="§"/>
             </a:pPr>
-            <a:endParaRPr lang="en-US" sz="2000" b="1" dirty="0"/>
-          </a:p>
-          <a:p>
-            <a:pPr marL="285750" indent="-285750">
+            <a:r>
+              <a:rPr lang="en-US" sz="2000" dirty="0"/>
+              <a:t>Profit.ag - $2,495 for lifetime access</a:t>
+            </a:r>
+          </a:p>
+          <a:p>
+            <a:pPr marL="1200150" lvl="2" indent="-285750">
               <a:buFont typeface="Wingdings" panose="05000000000000000000" pitchFamily="2" charset="2"/>
               <a:buChar char="§"/>
             </a:pPr>
             <a:r>
-              <a:rPr lang="en-US" sz="2000" b="1" dirty="0"/>
-              <a:t>This form can be filed online, but the formats the government accepts is very specific and complicated (XML) and any single mistake will cause it to be rejected.</a:t>
-            </a:r>
+              <a:rPr lang="en-US" sz="2000" dirty="0"/>
+              <a:t>PARS (Precision Acreage Reporting System)</a:t>
+            </a:r>
+          </a:p>
+          <a:p>
+            <a:pPr marL="800100" lvl="1" indent="-342900">
+              <a:buFont typeface="Arial" panose="020B0604020202020204" pitchFamily="34" charset="0"/>
+              <a:buChar char="•"/>
+            </a:pPr>
+            <a:r>
+              <a:rPr lang="en-US" sz="2000" dirty="0"/>
+              <a:t>Local FSA Service Centers</a:t>
+            </a:r>
+          </a:p>
+          <a:p>
+            <a:endParaRPr lang="en-US" sz="2000" b="1" dirty="0"/>
           </a:p>
         </p:txBody>
       </p:sp>
     </p:spTree>
     <p:extLst>
       <p:ext uri="{BB962C8B-B14F-4D97-AF65-F5344CB8AC3E}">
-        <p14:creationId xmlns:p14="http://schemas.microsoft.com/office/powerpoint/2010/main" val="2713165969"/>
+        <p14:creationId xmlns:p14="http://schemas.microsoft.com/office/powerpoint/2010/main" val="2255799835"/>
       </p:ext>
     </p:extLst>
   </p:cSld>

</xml_diff>